<commit_message>
Add SkillCall SIH26097 idea deck (Cognify) with PDF export
Six-slide deck in the official SIH 2026 IDEA format, built from the team's
reference file: problem, 6-step call flow, 8 highlights, tech stack with
logos, two-lane architecture, cost table with working, viability, risks,
impact numbers with calculations, and references. Also repairs duplicate
paragraph-property elements in the earlier test deck.

Co-Authored-By: Claude Fable 5.1 <noreply@anthropic.com>
Claude-Session: https://claude.ai/code/session_01XpLCUSjmNpNxHJ2vYpsyUF
</commit_message>
<xml_diff>
--- a/sih-26097/SIH26097_Kaushal_Saathi.pptx
+++ b/sih-26097/SIH26097_Kaushal_Saathi.pptx
@@ -7434,9 +7434,6 @@
               </a:rPr>
               <a:t>Ministry of Social Justice &amp; Empowerment  ·  </a:t>
             </a:r>
-            <a:pPr indent="0" marL="0">
-              <a:buNone/>
-            </a:pPr>
             <a:r>
               <a:rPr lang="en-US" sz="1050" u="sng" dirty="0">
                 <a:solidFill>
@@ -7575,9 +7572,6 @@
               </a:rPr>
               <a:t>NCVET  ·  </a:t>
             </a:r>
-            <a:pPr indent="0" marL="0">
-              <a:buNone/>
-            </a:pPr>
             <a:r>
               <a:rPr lang="en-US" sz="1050" u="sng" dirty="0">
                 <a:solidFill>
@@ -7716,9 +7710,6 @@
               </a:rPr>
               <a:t>MeitY  ·  </a:t>
             </a:r>
-            <a:pPr indent="0" marL="0">
-              <a:buNone/>
-            </a:pPr>
             <a:r>
               <a:rPr lang="en-US" sz="1050" u="sng" dirty="0">
                 <a:solidFill>
@@ -7857,9 +7848,6 @@
               </a:rPr>
               <a:t>AI4Bharat, IIT Madras  ·  </a:t>
             </a:r>
-            <a:pPr indent="0" marL="0">
-              <a:buNone/>
-            </a:pPr>
             <a:r>
               <a:rPr lang="en-US" sz="1050" u="sng" dirty="0">
                 <a:solidFill>
@@ -7998,9 +7986,6 @@
               </a:rPr>
               <a:t>MSDE  ·  </a:t>
             </a:r>
-            <a:pPr indent="0" marL="0">
-              <a:buNone/>
-            </a:pPr>
             <a:r>
               <a:rPr lang="en-US" sz="1050" u="sng" dirty="0">
                 <a:solidFill>
@@ -8139,9 +8124,6 @@
               </a:rPr>
               <a:t>Government of India  ·  </a:t>
             </a:r>
-            <a:pPr indent="0" marL="0">
-              <a:buNone/>
-            </a:pPr>
             <a:r>
               <a:rPr lang="en-US" sz="1050" u="sng" dirty="0">
                 <a:solidFill>

</xml_diff>